<commit_message>
slides: upgrade to Advanced 25pt — embedded figures, sharpened titles, tightened pacing
</commit_message>
<xml_diff>
--- a/slides/knowhow_appendix.pptx
+++ b/slides/knowhow_appendix.pptx
@@ -4074,16 +4074,39 @@
           </a:effectLst>
         </p:spPr>
       </p:sp>
-      <p:sp>
-        <p:nvSpPr>
-          <p:cNvPr id="11" name="Text 8"/>
-          <p:cNvSpPr/>
-          <p:nvPr/>
-        </p:nvSpPr>
-        <p:spPr>
-          <a:xfrm>
-            <a:off x="5212080" y="1417320"/>
-            <a:ext cx="3474720" cy="365760"/>
+      <p:pic>
+        <p:nvPicPr>
+          <p:cNvPr id="11" name="Image 0" descr="/Users/m2/Projects/STAT 5243/43 Project 4/figures/07_team_style_pca.png">    </p:cNvPr>
+          <p:cNvPicPr>
+            <a:picLocks noChangeAspect="1"/>
+          </p:cNvPicPr>
+          <p:nvPr/>
+        </p:nvPicPr>
+        <p:blipFill>
+          <a:blip r:embed="rId1"/>
+          <a:srcRect l="0" r="0" t="0" b="0"/>
+          <a:stretch/>
+        </p:blipFill>
+        <p:spPr>
+          <a:xfrm>
+            <a:off x="5257800" y="1371600"/>
+            <a:ext cx="3383280" cy="2926080"/>
+          </a:xfrm>
+          <a:prstGeom prst="rect">
+            <a:avLst/>
+          </a:prstGeom>
+        </p:spPr>
+      </p:pic>
+      <p:sp>
+        <p:nvSpPr>
+          <p:cNvPr id="12" name="Text 8"/>
+          <p:cNvSpPr/>
+          <p:nvPr/>
+        </p:nvSpPr>
+        <p:spPr>
+          <a:xfrm>
+            <a:off x="5212080" y="4343400"/>
+            <a:ext cx="3474720" cy="256032"/>
           </a:xfrm>
           <a:prstGeom prst="rect">
             <a:avLst/>
@@ -4099,54 +4122,15 @@
               <a:buNone/>
             </a:pPr>
             <a:r>
-              <a:rPr lang="en-US" sz="1000" b="1" spc="300" kern="0" dirty="0">
-                <a:solidFill>
-                  <a:srgbClr val="7FB3D5"/>
-                </a:solidFill>
-                <a:latin typeface="Calibri" pitchFamily="34" charset="0"/>
-                <a:ea typeface="Calibri" pitchFamily="34" charset="-122"/>
-                <a:cs typeface="Calibri" pitchFamily="34" charset="-120"/>
-              </a:rPr>
-              <a:t>PCA-2 SCATTER, K-MEANS COLOURED (placeholder)</a:t>
-            </a:r>
-            <a:endParaRPr lang="en-US" sz="1000" dirty="0"/>
-          </a:p>
-        </p:txBody>
-      </p:sp>
-      <p:sp>
-        <p:nvSpPr>
-          <p:cNvPr id="12" name="Text 9"/>
-          <p:cNvSpPr/>
-          <p:nvPr/>
-        </p:nvSpPr>
-        <p:spPr>
-          <a:xfrm>
-            <a:off x="5212080" y="4160520"/>
-            <a:ext cx="3474720" cy="274320"/>
-          </a:xfrm>
-          <a:prstGeom prst="rect">
-            <a:avLst/>
-          </a:prstGeom>
-          <a:noFill/>
-          <a:ln/>
-        </p:spPr>
-        <p:txBody>
-          <a:bodyPr wrap="square" lIns="0" tIns="0" rIns="0" bIns="0" rtlCol="0" anchor="ctr"/>
-          <a:lstStyle/>
-          <a:p>
-            <a:pPr algn="ctr" indent="0" marL="0">
-              <a:buNone/>
-            </a:pPr>
-            <a:r>
-              <a:rPr lang="en-US" sz="900" dirty="0">
+              <a:rPr lang="en-US" sz="900" i="1" dirty="0">
                 <a:solidFill>
                   <a:srgbClr val="5A6573"/>
                 </a:solidFill>
-                <a:latin typeface="Consolas" pitchFamily="34" charset="0"/>
-                <a:ea typeface="Consolas" pitchFamily="34" charset="-122"/>
-                <a:cs typeface="Consolas" pitchFamily="34" charset="-120"/>
-              </a:rPr>
-              <a:t>figures/pca_kmeans_scatter.png</a:t>
+                <a:latin typeface="Calibri" pitchFamily="34" charset="0"/>
+                <a:ea typeface="Calibri" pitchFamily="34" charset="-122"/>
+                <a:cs typeface="Calibri" pitchFamily="34" charset="-120"/>
+              </a:rPr>
+              <a:t>PCA-2 with K-means (k=4) — see clusters identified on facing page.</a:t>
             </a:r>
             <a:endParaRPr lang="en-US" sz="900" dirty="0"/>
           </a:p>
@@ -10661,16 +10645,39 @@
           </a:effectLst>
         </p:spPr>
       </p:sp>
-      <p:sp>
-        <p:nvSpPr>
-          <p:cNvPr id="26" name="Text 24"/>
-          <p:cNvSpPr/>
-          <p:nvPr/>
-        </p:nvSpPr>
-        <p:spPr>
-          <a:xfrm>
-            <a:off x="4937760" y="3154680"/>
-            <a:ext cx="3749040" cy="274320"/>
+      <p:pic>
+        <p:nvPicPr>
+          <p:cNvPr id="26" name="Image 0" descr="/Users/m2/Projects/STAT 5243/43 Project 4/figures/09_market_calibration.png">    </p:cNvPr>
+          <p:cNvPicPr>
+            <a:picLocks noChangeAspect="1"/>
+          </p:cNvPicPr>
+          <p:nvPr/>
+        </p:nvPicPr>
+        <p:blipFill>
+          <a:blip r:embed="rId1"/>
+          <a:srcRect l="0" r="0" t="0" b="0"/>
+          <a:stretch/>
+        </p:blipFill>
+        <p:spPr>
+          <a:xfrm>
+            <a:off x="4983480" y="3054096"/>
+            <a:ext cx="3657600" cy="1298448"/>
+          </a:xfrm>
+          <a:prstGeom prst="rect">
+            <a:avLst/>
+          </a:prstGeom>
+        </p:spPr>
+      </p:pic>
+      <p:sp>
+        <p:nvSpPr>
+          <p:cNvPr id="27" name="Text 24"/>
+          <p:cNvSpPr/>
+          <p:nvPr/>
+        </p:nvSpPr>
+        <p:spPr>
+          <a:xfrm>
+            <a:off x="4937760" y="4370832"/>
+            <a:ext cx="3749040" cy="228600"/>
           </a:xfrm>
           <a:prstGeom prst="rect">
             <a:avLst/>
@@ -10686,95 +10693,17 @@
               <a:buNone/>
             </a:pPr>
             <a:r>
-              <a:rPr lang="en-US" sz="1000" b="1" spc="300" kern="0" dirty="0">
-                <a:solidFill>
-                  <a:srgbClr val="7FB3D5"/>
-                </a:solidFill>
-                <a:latin typeface="Calibri" pitchFamily="34" charset="0"/>
-                <a:ea typeface="Calibri" pitchFamily="34" charset="-122"/>
-                <a:cs typeface="Calibri" pitchFamily="34" charset="-120"/>
-              </a:rPr>
-              <a:t>RELIABILITY DIAGRAM (placeholder)</a:t>
-            </a:r>
-            <a:endParaRPr lang="en-US" sz="1000" dirty="0"/>
-          </a:p>
-        </p:txBody>
-      </p:sp>
-      <p:sp>
-        <p:nvSpPr>
-          <p:cNvPr id="27" name="Text 25"/>
-          <p:cNvSpPr/>
-          <p:nvPr/>
-        </p:nvSpPr>
-        <p:spPr>
-          <a:xfrm>
-            <a:off x="4937760" y="3749040"/>
-            <a:ext cx="3749040" cy="228600"/>
-          </a:xfrm>
-          <a:prstGeom prst="rect">
-            <a:avLst/>
-          </a:prstGeom>
-          <a:noFill/>
-          <a:ln/>
-        </p:spPr>
-        <p:txBody>
-          <a:bodyPr wrap="square" lIns="0" tIns="0" rIns="0" bIns="0" rtlCol="0" anchor="ctr"/>
-          <a:lstStyle/>
-          <a:p>
-            <a:pPr algn="ctr" indent="0" marL="0">
-              <a:buNone/>
-            </a:pPr>
-            <a:r>
-              <a:rPr lang="en-US" sz="900" dirty="0">
+              <a:rPr lang="en-US" sz="950" i="1" dirty="0">
                 <a:solidFill>
                   <a:srgbClr val="5A6573"/>
                 </a:solidFill>
-                <a:latin typeface="Consolas" pitchFamily="34" charset="0"/>
-                <a:ea typeface="Consolas" pitchFamily="34" charset="-122"/>
-                <a:cs typeface="Consolas" pitchFamily="34" charset="-120"/>
-              </a:rPr>
-              <a:t>figures/calibration_plot.png</a:t>
-            </a:r>
-            <a:endParaRPr lang="en-US" sz="900" dirty="0"/>
-          </a:p>
-        </p:txBody>
-      </p:sp>
-      <p:sp>
-        <p:nvSpPr>
-          <p:cNvPr id="28" name="Text 26"/>
-          <p:cNvSpPr/>
-          <p:nvPr/>
-        </p:nvSpPr>
-        <p:spPr>
-          <a:xfrm>
-            <a:off x="4937760" y="4251960"/>
-            <a:ext cx="3749040" cy="274320"/>
-          </a:xfrm>
-          <a:prstGeom prst="rect">
-            <a:avLst/>
-          </a:prstGeom>
-          <a:noFill/>
-          <a:ln/>
-        </p:spPr>
-        <p:txBody>
-          <a:bodyPr wrap="square" lIns="0" tIns="0" rIns="0" bIns="0" rtlCol="0" anchor="ctr"/>
-          <a:lstStyle/>
-          <a:p>
-            <a:pPr algn="ctr" indent="0" marL="0">
-              <a:buNone/>
-            </a:pPr>
-            <a:r>
-              <a:rPr lang="en-US" sz="1000" i="1" dirty="0">
-                <a:solidFill>
-                  <a:srgbClr val="5A6573"/>
-                </a:solidFill>
-                <a:latin typeface="Calibri" pitchFamily="34" charset="0"/>
-                <a:ea typeface="Calibri" pitchFamily="34" charset="-122"/>
-                <a:cs typeface="Calibri" pitchFamily="34" charset="-120"/>
-              </a:rPr>
-              <a:t>Diagonal = perfectly calibrated. We plot it for every model.</a:t>
-            </a:r>
-            <a:endParaRPr lang="en-US" sz="1000" dirty="0"/>
+                <a:latin typeface="Calibri" pitchFamily="34" charset="0"/>
+                <a:ea typeface="Calibri" pitchFamily="34" charset="-122"/>
+                <a:cs typeface="Calibri" pitchFamily="34" charset="-120"/>
+              </a:rPr>
+              <a:t>Pinnacle close: essentially on the diagonal — pure calibration.</a:t>
+            </a:r>
+            <a:endParaRPr lang="en-US" sz="950" dirty="0"/>
           </a:p>
         </p:txBody>
       </p:sp>

</xml_diff>